<commit_message>
Render and inspect every presentation slide locally
Publish the PDF, full-resolution slide images, contact sheet, and hash-bound validation. Verify every slide visually, keep body text at least 20pt, and preserve matching rendering evidence on identical regeneration.

Co-authored-by: Copilot <223556219+Copilot@users.noreply.github.com>
</commit_message>
<xml_diff>
--- a/demo/Agentic-Quant-Lab-Demo.pptx
+++ b/demo/Agentic-Quant-Lab-Demo.pptx
@@ -2768,7 +2768,12 @@
           </a:p>
           <a:p>
             <a:r>
-              <a:t>drawdown magnitude. Keep drawdown labels signed negative. No fabricated series.</a:t>
+              <a:t>drawdown magnitude. Keep drawdown labels signed negative and the</a:t>
+            </a:r>
+          </a:p>
+          <a:p>
+            <a:r>
+              <a:t>NOT PRODUCTION-READY qualification prominent at 20 pt. No fabricated series.</a:t>
             </a:r>
           </a:p>
           <a:p>
@@ -15444,8 +15449,8 @@
         </p:nvSpPr>
         <p:spPr>
           <a:xfrm>
-            <a:off x="731520" y="5413248"/>
-            <a:ext cx="3291840" cy="429768"/>
+            <a:off x="731520" y="5367528"/>
+            <a:ext cx="3291840" cy="621792"/>
           </a:xfrm>
           <a:prstGeom prst="rect">
             <a:avLst/>
@@ -21620,14 +21625,14 @@
       </p:sp>
       <p:sp>
         <p:nvSpPr>
-          <p:cNvPr id="55" name="metadata-text-55"/>
+          <p:cNvPr id="55" name="body-text-55"/>
           <p:cNvSpPr txBox="1"/>
           <p:nvPr/>
         </p:nvSpPr>
         <p:spPr>
           <a:xfrm>
             <a:off x="502920" y="521207"/>
-            <a:ext cx="10972800" cy="219456"/>
+            <a:ext cx="10972800" cy="329184"/>
           </a:xfrm>
           <a:prstGeom prst="rect">
             <a:avLst/>
@@ -21650,7 +21655,7 @@
               <a:spcAft>
                 <a:spcPts val="0"/>
               </a:spcAft>
-              <a:defRPr sz="1600" b="1">
+              <a:defRPr sz="2000" b="1">
                 <a:solidFill>
                   <a:srgbClr val="6DE5C1"/>
                 </a:solidFill>
@@ -21665,7 +21670,52 @@
       </p:sp>
       <p:sp>
         <p:nvSpPr>
-          <p:cNvPr id="56" name="metadata-text-56"/>
+          <p:cNvPr id="56" name="body-text-56"/>
+          <p:cNvSpPr txBox="1"/>
+          <p:nvPr/>
+        </p:nvSpPr>
+        <p:spPr>
+          <a:xfrm>
+            <a:off x="7955279" y="1828800"/>
+            <a:ext cx="3730752" cy="320040"/>
+          </a:xfrm>
+          <a:prstGeom prst="rect">
+            <a:avLst/>
+          </a:prstGeom>
+          <a:noFill/>
+        </p:spPr>
+        <p:txBody>
+          <a:bodyPr wrap="square" lIns="0" rIns="0" tIns="0" bIns="0" anchor="ctr">
+            <a:spAutoFit/>
+          </a:bodyPr>
+          <a:lstStyle/>
+          <a:p>
+            <a:pPr algn="l">
+              <a:lnSpc>
+                <a:spcPct val="105000"/>
+              </a:lnSpc>
+              <a:spcBef>
+                <a:spcPts val="0"/>
+              </a:spcBef>
+              <a:spcAft>
+                <a:spcPts val="0"/>
+              </a:spcAft>
+              <a:defRPr sz="2000" b="1">
+                <a:solidFill>
+                  <a:srgbClr val="F5C978"/>
+                </a:solidFill>
+                <a:latin typeface="Arial"/>
+              </a:defRPr>
+            </a:pPr>
+            <a:r>
+              <a:t>NOT PRODUCTION-READY</a:t>
+            </a:r>
+          </a:p>
+        </p:txBody>
+      </p:sp>
+      <p:sp>
+        <p:nvSpPr>
+          <p:cNvPr id="57" name="metadata-text-57"/>
           <p:cNvSpPr txBox="1"/>
           <p:nvPr/>
         </p:nvSpPr>
@@ -21703,7 +21753,7 @@
               </a:defRPr>
             </a:pPr>
             <a:r>
-              <a:t>NOT PRODUCTION-READY · NAV proxy, not executable closes.</a:t>
+              <a:t>NAV proxy, not executable closes.</a:t>
             </a:r>
           </a:p>
         </p:txBody>

</xml_diff>

<commit_message>
Finish the demo landing page and verified offline fallback package
Capture the successful deterministic transcript and matching dashboard/receipt, add presentation-package regression tests, and clarify rounded trend comparisons in speaker notes. Verify 77 focused tests, project type checking, lint/format, offline package build, and documented slide regeneration.

Co-authored-by: Copilot <223556219+Copilot@users.noreply.github.com>
</commit_message>
<xml_diff>
--- a/demo/Agentic-Quant-Lab-Demo.pptx
+++ b/demo/Agentic-Quant-Lab-Demo.pptx
@@ -2649,6 +2649,22 @@
           <a:p/>
           <a:p>
             <a:r>
+              <a:t>Static 70/30 and Absolute12 both round to 11.26%; Absolute12's exact CAGR is</a:t>
+            </a:r>
+          </a:p>
+          <a:p>
+            <a:r>
+              <a:t>slightly higher. The comparison is the drawdown trade-off, not a claim that</a:t>
+            </a:r>
+          </a:p>
+          <a:p>
+            <a:r>
+              <a:t>static 70/30 has a higher CAGR.</a:t>
+            </a:r>
+          </a:p>
+          <a:p/>
+          <a:p>
+            <a:r>
               <a:t>The whipsaw counts are **completed defensive cycles losing relative wealth</a:t>
             </a:r>
           </a:p>
@@ -2820,7 +2836,22 @@
           <a:p/>
           <a:p>
             <a:r>
-              <a:t>Static splits mean SPY/BIL, not stock/aggregate bonds. The 4/4 and 9/11</a:t>
+              <a:t>Static splits mean SPY/BIL, not stock/aggregate bonds. Static 70/30 and</a:t>
+            </a:r>
+          </a:p>
+          <a:p>
+            <a:r>
+              <a:t>Absolute12 have the same rounded CAGR, not exactly equal growth; Absolute12's</a:t>
+            </a:r>
+          </a:p>
+          <a:p>
+            <a:r>
+              <a:t>exact CAGR is slightly higher. Compare their drawdowns, not strict CAGR dominance.</a:t>
+            </a:r>
+          </a:p>
+          <a:p>
+            <a:r>
+              <a:t>The 4/4 and 9/11</a:t>
             </a:r>
           </a:p>
           <a:p>

</xml_diff>